<commit_message>
refactor: plain English railway deck text, preserve full technical features
</commit_message>
<xml_diff>
--- a/SETU_SIH2026_Idea_Presentation.pptx
+++ b/SETU_SIH2026_Idea_Presentation.pptx
@@ -5848,7 +5848,7 @@
               </a:defRPr>
             </a:pPr>
             <a:r>
-              <a:t>CORE PARADIGM: CROSS-DEPARTMENT SHADOW CONVOYS</a:t>
+              <a:t>THE CORE IDEA: COMBINING THREE SHUTDOWNS INTO ONE</a:t>
             </a:r>
           </a:p>
         </p:txBody>
@@ -5946,7 +5946,7 @@
               </a:defRPr>
             </a:pPr>
             <a:r>
-              <a:t>CURRENT PRACTICE: 3 DISJOINTED TRACK SHUTDOWNS (14.2h Lost)</a:t>
+              <a:t>TODAY'S PRACTICE: 3 SEPARATE TRACK SHUTDOWNS (14.2h Lost)</a:t>
             </a:r>
           </a:p>
         </p:txBody>
@@ -5999,7 +5999,7 @@
               </a:defRPr>
             </a:pPr>
             <a:r>
-              <a:t>Track (P-Way): 09:00 - 12:00 (180m)</a:t>
+              <a:t>Track (P-Way): 09:00 - 12:00 (3h)</a:t>
             </a:r>
           </a:p>
         </p:txBody>
@@ -6052,7 +6052,7 @@
               </a:defRPr>
             </a:pPr>
             <a:r>
-              <a:t>TRD (OHE): 13:30 - 15:30 (120m)</a:t>
+              <a:t>Electrical (TRD): 13:30 - 15:30 (2h)</a:t>
             </a:r>
           </a:p>
         </p:txBody>
@@ -6105,7 +6105,7 @@
               </a:defRPr>
             </a:pPr>
             <a:r>
-              <a:t>S&amp;T: 16:30 (90m)</a:t>
+              <a:t>Signals: 16:30 (1.5h)</a:t>
             </a:r>
           </a:p>
         </p:txBody>
@@ -6141,7 +6141,7 @@
               </a:defRPr>
             </a:pPr>
             <a:r>
-              <a:t>3 Separate Traffic Halts | Repeated Speed Restrictions | Compounded Freight Stagnation</a:t>
+              <a:t>Trains halted 3 times a day | Freight held in sidings | Severe passenger delays</a:t>
             </a:r>
           </a:p>
         </p:txBody>
@@ -6177,7 +6177,7 @@
               </a:defRPr>
             </a:pPr>
             <a:r>
-              <a:t>v   SETU CP-SAT BUNDLING &amp; DETERMINISTIC SAFETY GATE   v</a:t>
+              <a:t>v   SETU SMART OPTIMIZATION &amp; RAILWAY SAFETY CHECK   v</a:t>
             </a:r>
           </a:p>
         </p:txBody>
@@ -6275,7 +6275,7 @@
               </a:defRPr>
             </a:pPr>
             <a:r>
-              <a:t>SETU REVOLUTION: 1 UNIFIED SHADOW CONVOY WINDOW</a:t>
+              <a:t>SETU INNOVATION: 1 COMBINED MAINTENANCE WINDOW</a:t>
             </a:r>
           </a:p>
         </p:txBody>
@@ -6373,7 +6373,7 @@
               </a:defRPr>
             </a:pPr>
             <a:r>
-              <a:t>ENG: CSM Tamping Machine (Km 102.0 - 104.5)</a:t>
+              <a:t>Track: Heavy Tamping Machine works along rails (Km 102.0 - 104.5)</a:t>
             </a:r>
           </a:p>
         </p:txBody>
@@ -6418,7 +6418,7 @@
           <a:lstStyle/>
           <a:p>
             <a:pPr algn="ctr">
-              <a:defRPr sz="700" b="1">
+              <a:defRPr sz="680" b="1">
                 <a:solidFill>
                   <a:srgbClr val="F8FAFC"/>
                 </a:solidFill>
@@ -6426,7 +6426,7 @@
               </a:defRPr>
             </a:pPr>
             <a:r>
-              <a:t>TRD: Catenary Tower Car (Km 102.5 - 104.0) [Certified 25kV Cut]</a:t>
+              <a:t>Electrical: Tower Car checks wires under certified 25kV power cut (Km 102.5 - 104.0)</a:t>
             </a:r>
           </a:p>
         </p:txBody>
@@ -6479,7 +6479,7 @@
               </a:defRPr>
             </a:pPr>
             <a:r>
-              <a:t>S&amp;T: Point Testing (Km 104.2)</a:t>
+              <a:t>Signals: Point switch testing (Km 104.2)</a:t>
             </a:r>
           </a:p>
         </p:txBody>
@@ -6515,7 +6515,7 @@
               </a:defRPr>
             </a:pPr>
             <a:r>
-              <a:t>1 Single Integrated Window (210 min)  |  180 min Track Time Returned to Traffic</a:t>
+              <a:t>1 Single Combined Window (210 min)  |  Saves 180 min of track time for running trains</a:t>
             </a:r>
           </a:p>
           <a:p>
@@ -6528,7 +6528,7 @@
               </a:defRPr>
             </a:pPr>
             <a:r>
-              <a:t>Zero passenger train disruption  *  100% G&amp;SR safety clearance buffers verified</a:t>
+              <a:t>Zero passenger train disruption  *  100% official railway safety buffer verified</a:t>
             </a:r>
           </a:p>
         </p:txBody>
@@ -6939,7 +6939,7 @@
               </a:defRPr>
             </a:pPr>
             <a:r>
-              <a:t>CURRENT REALITY: DEPARTMENTAL SILOS</a:t>
+              <a:t>TODAY'S REALITY: DEPARTMENT SILOS</a:t>
             </a:r>
           </a:p>
         </p:txBody>
@@ -6978,7 +6978,7 @@
               </a:defRPr>
             </a:pPr>
             <a:r>
-              <a:t>* Civil Eng (Track): Submits 09:00-12:00 block -&gt; 180 min track closure</a:t>
+              <a:t>* Track Team (P-Way): Requests 09:00 - 12:00 block -&gt; 180 min track closure</a:t>
             </a:r>
           </a:p>
           <a:p>
@@ -6994,13 +6994,13 @@
               </a:defRPr>
             </a:pPr>
             <a:r>
-              <a:t>* TRD (OHE): Submits 13:30-15:30 block -&gt; 120 min track closure</a:t>
+              <a:t>* Electrical Team (TRD): Requests 13:30 - 15:30 block -&gt; 120 min track closure</a:t>
             </a:r>
           </a:p>
           <a:p>
             <a:pPr algn="l">
               <a:spcAft>
-                <a:spcPts val="800"/>
+                <a:spcPts val="600"/>
               </a:spcAft>
               <a:defRPr sz="950" b="0">
                 <a:solidFill>
@@ -7010,12 +7010,12 @@
               </a:defRPr>
             </a:pPr>
             <a:r>
-              <a:t>* S&amp;T (Signals): Submits 16:30-18:00 block -&gt; 90 min track closure</a:t>
+              <a:t>* Signal Team (S&amp;T): Requests 16:30 - 18:00 block -&gt; 90 min track closure</a:t>
             </a:r>
           </a:p>
           <a:p>
             <a:pPr algn="l">
-              <a:defRPr sz="950" b="1">
+              <a:defRPr sz="900" b="1">
                 <a:solidFill>
                   <a:srgbClr val="EF4444"/>
                 </a:solidFill>
@@ -7023,7 +7023,7 @@
               </a:defRPr>
             </a:pPr>
             <a:r>
-              <a:t>BOTTLENECK: 3 Separate Track Closures (390 min total lost). Section controllers juggle paper forms. Freight held at outer loops.</a:t>
+              <a:t>THE BOTTLENECK: 3 Separate Track Closures (390 min total lost). Section controllers manage paper forms &amp; phone calls. Freight held at outer loops, causing ripple delays across the network.</a:t>
             </a:r>
           </a:p>
         </p:txBody>
@@ -7121,7 +7121,7 @@
               </a:defRPr>
             </a:pPr>
             <a:r>
-              <a:t>THE SETU REVOLUTION: SYNCHRONIZED SHADOW CONVOY</a:t>
+              <a:t>THE SETU REVOLUTION: SYNCHRONIZED WORK WINDOWS</a:t>
             </a:r>
           </a:p>
         </p:txBody>
@@ -7160,7 +7160,7 @@
               </a:defRPr>
             </a:pPr>
             <a:r>
-              <a:t>UNIFIED PROTECTED CORRIDOR WINDOW: 11:00 - 14:30 (210 min active possession)</a:t>
+              <a:t>ONE COMBINED TRACK WINDOW: 11:00 - 14:30 (210 min active work)</a:t>
             </a:r>
           </a:p>
           <a:p>
@@ -7176,7 +7176,7 @@
               </a:defRPr>
             </a:pPr>
             <a:r>
-              <a:t>* Eng: Tamping Machine operates Km 102.0 to 104.5 (P-Way output maximized)</a:t>
+              <a:t>* Track Team: Tamping machine works on track from Km 102.0 to 104.5.</a:t>
             </a:r>
           </a:p>
           <a:p>
@@ -7192,7 +7192,7 @@
               </a:defRPr>
             </a:pPr>
             <a:r>
-              <a:t>* TRD: OHE Ladder Car operates Km 102.5 to 104.0 under certified 25kV power cut</a:t>
+              <a:t>* Electrical Team: Overhead wire inspection from Km 102.5 to 104.0 under certified power cut.</a:t>
             </a:r>
           </a:p>
           <a:p>
@@ -7208,7 +7208,7 @@
               </a:defRPr>
             </a:pPr>
             <a:r>
-              <a:t>* S&amp;T: Interlocking Point Machine tested concurrently at Km 104.2 crossover</a:t>
+              <a:t>* Signal Team: Track crossover switches and point machine tested at Km 104.2 junction.</a:t>
             </a:r>
           </a:p>
           <a:p>
@@ -7221,7 +7221,7 @@
               </a:defRPr>
             </a:pPr>
             <a:r>
-              <a:t>RESULT: 1 Single Corridor Closure instead of 3. Saved 180 min of active track time. Headways preserved for Rajdhani &amp; container freight rakes.</a:t>
+              <a:t>BREAKTHROUGH RESULT: 1 Track Closure instead of 3. Returns 180 min of track time back to passenger express &amp; freight trains. Zero train cancellations.</a:t>
             </a:r>
           </a:p>
         </p:txBody>
@@ -7319,7 +7319,7 @@
               </a:defRPr>
             </a:pPr>
             <a:r>
-              <a:t>1. SHARED ASSET DEMAND LEDGER</a:t>
+              <a:t>1. ONE SHARED DIGITAL HUB</a:t>
             </a:r>
           </a:p>
         </p:txBody>
@@ -7358,7 +7358,7 @@
               </a:defRPr>
             </a:pPr>
             <a:r>
-              <a:t>Unified Multi-Dept Ingestion</a:t>
+              <a:t>Unified Multi-Department Queue</a:t>
             </a:r>
           </a:p>
           <a:p>
@@ -7374,7 +7374,7 @@
               </a:defRPr>
             </a:pPr>
             <a:r>
-              <a:t>Ingests pending maintenance work orders from Civil Eng, TRD, and S&amp;T into a single standardized operational queue.</a:t>
+              <a:t>Brings maintenance requests from Track, Electrical, and Signal teams into one shared digital system.</a:t>
             </a:r>
           </a:p>
           <a:p>
@@ -7387,7 +7387,7 @@
               </a:defRPr>
             </a:pPr>
             <a:r>
-              <a:t>* Replaces fragmented paper &amp; phone requests with unified spatio-temporal state.</a:t>
+              <a:t>* Replaces scattered paper forms and phone calls with one clear view of all upcoming work.</a:t>
             </a:r>
           </a:p>
         </p:txBody>
@@ -7485,7 +7485,7 @@
               </a:defRPr>
             </a:pPr>
             <a:r>
-              <a:t>2. SPATIO-TEMPORAL CONVOY PACKING</a:t>
+              <a:t>2. SMART WORK BUNDLING</a:t>
             </a:r>
           </a:p>
         </p:txBody>
@@ -7524,7 +7524,7 @@
               </a:defRPr>
             </a:pPr>
             <a:r>
-              <a:t>Google OR-Tools CP-SAT Bundling</a:t>
+              <a:t>Coordinated Multi-Job Scheduling</a:t>
             </a:r>
           </a:p>
           <a:p>
@@ -7540,7 +7540,7 @@
               </a:defRPr>
             </a:pPr>
             <a:r>
-              <a:t>Algorithmically discovers compatible multi-department tasks on the same track segment. Enforces 500m safety clearance buffers.</a:t>
+              <a:t>Our optimization engine groups compatible repair jobs in the same track section to run together.</a:t>
             </a:r>
           </a:p>
           <a:p>
@@ -7553,7 +7553,7 @@
               </a:defRPr>
             </a:pPr>
             <a:r>
-              <a:t>* Guarantees OHE 25kV de-energization window strictly encloses ground maintenance.</a:t>
+              <a:t>* Enforces 500m safety buffers and guarantees overhead 25kV power cut before work starts.</a:t>
             </a:r>
           </a:p>
         </p:txBody>
@@ -7651,7 +7651,7 @@
               </a:defRPr>
             </a:pPr>
             <a:r>
-              <a:t>3. TIMETABLE MARGIN INTEGRATION</a:t>
+              <a:t>3. TIMETABLE GAP MATCHING</a:t>
             </a:r>
           </a:p>
         </p:txBody>
@@ -7690,7 +7690,7 @@
               </a:defRPr>
             </a:pPr>
             <a:r>
-              <a:t>Corridor Headway Awareness</a:t>
+              <a:t>Protecting Train Punctuality</a:t>
             </a:r>
           </a:p>
           <a:p>
@@ -7706,7 +7706,7 @@
               </a:defRPr>
             </a:pPr>
             <a:r>
-              <a:t>Snaps joint possession envelopes into natural timetable white margins between scheduled passenger and freight trains.</a:t>
+              <a:t>Fits maintenance windows directly into natural time gaps between scheduled passenger and freight trains.</a:t>
             </a:r>
           </a:p>
           <a:p>
@@ -7719,7 +7719,7 @@
               </a:defRPr>
             </a:pPr>
             <a:r>
-              <a:t>* Eliminates unscheduled passenger stops at outer home signals.</a:t>
+              <a:t>* Protects high-speed trains (Rajdhani, Vande Bharat) and keeps freight rakes moving.</a:t>
             </a:r>
           </a:p>
         </p:txBody>
@@ -8179,7 +8179,7 @@
               </a:defRPr>
             </a:pPr>
             <a:r>
-              <a:t>Optimization solver core, constraint formulation, G&amp;SR safety audit, FastAPI backend.</a:t>
+              <a:t>Powers scheduling optimization, safety verification rules, and FastAPI backend.</a:t>
             </a:r>
           </a:p>
           <a:p>
@@ -8195,7 +8195,7 @@
               </a:defRPr>
             </a:pPr>
             <a:r>
-              <a:t>TypeScript 5.x / ES2024</a:t>
+              <a:t>TypeScript &amp; JavaScript</a:t>
             </a:r>
           </a:p>
           <a:p>
@@ -8211,7 +8211,7 @@
               </a:defRPr>
             </a:pPr>
             <a:r>
-              <a:t>Type-safe interactive dashboard, modular React components, client state engine.</a:t>
+              <a:t>Delivers a fast, interactive, type-safe web dashboard for operators.</a:t>
             </a:r>
           </a:p>
           <a:p>
@@ -8227,7 +8227,7 @@
               </a:defRPr>
             </a:pPr>
             <a:r>
-              <a:t>Bash / PowerShell</a:t>
+              <a:t>Automated Scripting</a:t>
             </a:r>
           </a:p>
           <a:p>
@@ -8243,7 +8243,7 @@
               </a:defRPr>
             </a:pPr>
             <a:r>
-              <a:t>Automated test runner &amp; CI/CD reproduction.</a:t>
+              <a:t>Automated end-to-end verification and testing pipelines.</a:t>
             </a:r>
           </a:p>
         </p:txBody>
@@ -8341,7 +8341,7 @@
               </a:defRPr>
             </a:pPr>
             <a:r>
-              <a:t>FRAMEWORKS &amp; LIBRARIES</a:t>
+              <a:t>FRAMEWORKS &amp; TOOLS</a:t>
             </a:r>
           </a:p>
         </p:txBody>
@@ -8396,7 +8396,7 @@
               </a:defRPr>
             </a:pPr>
             <a:r>
-              <a:t>High-throughput async REST API, auto OpenAPI specs.</a:t>
+              <a:t>High-speed async backend that handles live schedules and requests instantly.</a:t>
             </a:r>
           </a:p>
           <a:p>
@@ -8412,7 +8412,7 @@
               </a:defRPr>
             </a:pPr>
             <a:r>
-              <a:t>React 19 + Vite + Tailwind</a:t>
+              <a:t>React 19 + Tailwind CSS</a:t>
             </a:r>
           </a:p>
           <a:p>
@@ -8428,7 +8428,7 @@
               </a:defRPr>
             </a:pPr>
             <a:r>
-              <a:t>Sub-second HMR, modular UI cards, dark theme styling.</a:t>
+              <a:t>Clean, responsive operator interface with dark-mode night-shift theme.</a:t>
             </a:r>
           </a:p>
           <a:p>
@@ -8444,7 +8444,7 @@
               </a:defRPr>
             </a:pPr>
             <a:r>
-              <a:t>Pydantic v2 &amp; NetworkX</a:t>
+              <a:t>Data &amp; Network Tools</a:t>
             </a:r>
           </a:p>
           <a:p>
@@ -8460,7 +8460,7 @@
               </a:defRPr>
             </a:pPr>
             <a:r>
-              <a:t>Strict schema validation &amp; 1-hop network graph topology.</a:t>
+              <a:t>Pydantic v2 schema validation and track connection graph models.</a:t>
             </a:r>
           </a:p>
         </p:txBody>
@@ -8558,7 +8558,7 @@
               </a:defRPr>
             </a:pPr>
             <a:r>
-              <a:t>OPTIMIZATION &amp; AI/ML</a:t>
+              <a:t>OPTIMIZATION &amp; LOGIC</a:t>
             </a:r>
           </a:p>
         </p:txBody>
@@ -8613,7 +8613,7 @@
               </a:defRPr>
             </a:pPr>
             <a:r>
-              <a:t>Constraint Programming with SAT solving for multi-knapsack interval scheduling.</a:t>
+              <a:t>Mathematically searches thousands of schedule combinations in seconds to find the best plan.</a:t>
             </a:r>
           </a:p>
           <a:p>
@@ -8629,7 +8629,7 @@
               </a:defRPr>
             </a:pPr>
             <a:r>
-              <a:t>scikit-learn (Regression)</a:t>
+              <a:t>Predictive Machine Learning</a:t>
             </a:r>
           </a:p>
           <a:p>
@@ -8645,7 +8645,7 @@
               </a:defRPr>
             </a:pPr>
             <a:r>
-              <a:t>Task duration variance &amp; overrun risk forecasting.</a:t>
+              <a:t>Estimates realistic job duration based on weather and equipment type.</a:t>
             </a:r>
           </a:p>
           <a:p>
@@ -8661,7 +8661,7 @@
               </a:defRPr>
             </a:pPr>
             <a:r>
-              <a:t>Deterministic Rule Engine</a:t>
+              <a:t>Independent Safety Gate</a:t>
             </a:r>
           </a:p>
           <a:p>
@@ -8677,7 +8677,7 @@
               </a:defRPr>
             </a:pPr>
             <a:r>
-              <a:t>Zero-hallucination G&amp;SR safety gate (55 unit tests).</a:t>
+              <a:t>Zero-hallucination code that verifies official railway safety rules (55 unit tests).</a:t>
             </a:r>
           </a:p>
         </p:txBody>
@@ -8814,7 +8814,7 @@
               </a:defRPr>
             </a:pPr>
             <a:r>
-              <a:t>Divisional On-Prem Server</a:t>
+              <a:t>Control Office Servers</a:t>
             </a:r>
           </a:p>
           <a:p>
@@ -8830,7 +8830,7 @@
               </a:defRPr>
             </a:pPr>
             <a:r>
-              <a:t>Linux Ubuntu 22.04 LTS, containerized Docker microservices.</a:t>
+              <a:t>Runs on standard railway division computers (Linux Ubuntu / Windows Server).</a:t>
             </a:r>
           </a:p>
           <a:p>
@@ -8862,7 +8862,7 @@
               </a:defRPr>
             </a:pPr>
             <a:r>
-              <a:t>Dual-monitor Section Controller &amp; Station Master terminals.</a:t>
+              <a:t>Dual-monitor dashboard for Section Controllers and Station Masters.</a:t>
             </a:r>
           </a:p>
           <a:p>
@@ -8878,7 +8878,7 @@
               </a:defRPr>
             </a:pPr>
             <a:r>
-              <a:t>Rugged Field PWA &amp; Redis</a:t>
+              <a:t>Mobile Field Access</a:t>
             </a:r>
           </a:p>
           <a:p>
@@ -8894,7 +8894,7 @@
               </a:defRPr>
             </a:pPr>
             <a:r>
-              <a:t>Handheld worker portal; Redis sub-second replan cache.</a:t>
+              <a:t>Web access on handheld tablets/phones for supervisors at track sites.</a:t>
             </a:r>
           </a:p>
         </p:txBody>
@@ -8992,7 +8992,7 @@
               </a:defRPr>
             </a:pPr>
             <a:r>
-              <a:t>METHODOLOGY: 5-STAGE OPERATIONAL IMPLEMENTATION PIPELINE</a:t>
+              <a:t>METHODOLOGY: 5-STEP OPERATIONAL IMPLEMENTATION PIPELINE</a:t>
             </a:r>
           </a:p>
         </p:txBody>
@@ -9090,7 +9090,7 @@
               </a:defRPr>
             </a:pPr>
             <a:r>
-              <a:t>STAGE 1: DATA INGESTION</a:t>
+              <a:t>STAGE 1: GATHER DEMANDS</a:t>
             </a:r>
           </a:p>
         </p:txBody>
@@ -9126,7 +9126,7 @@
               </a:defRPr>
             </a:pPr>
             <a:r>
-              <a:t>Normalizes Eng/TRD/S&amp;T work orders + NTES passenger timetables into unified JSON schema.</a:t>
+              <a:t>Normalizes Track, Electrical, and Signal requests + public timetables into one shared format.</a:t>
             </a:r>
           </a:p>
         </p:txBody>
@@ -9224,7 +9224,7 @@
               </a:defRPr>
             </a:pPr>
             <a:r>
-              <a:t>STAGE 2: ML DURATION ESTIMATION</a:t>
+              <a:t>STAGE 2: ESTIMATE DURATION</a:t>
             </a:r>
           </a:p>
         </p:txBody>
@@ -9260,7 +9260,7 @@
               </a:defRPr>
             </a:pPr>
             <a:r>
-              <a:t>Predicts task duration variance based on machine type, weather, and historical delay logs.</a:t>
+              <a:t>Machine learning predicts realistic job durations and flags urgent repairs based on past logs.</a:t>
             </a:r>
           </a:p>
         </p:txBody>
@@ -9358,7 +9358,7 @@
               </a:defRPr>
             </a:pPr>
             <a:r>
-              <a:t>STAGE 3: CP-SAT OPTIMIZATION</a:t>
+              <a:t>STAGE 3: FIND OPTIMAL SCHEDULE</a:t>
             </a:r>
           </a:p>
         </p:txBody>
@@ -9394,7 +9394,7 @@
               </a:defRPr>
             </a:pPr>
             <a:r>
-              <a:t>Google OR-Tools bundles compatible orders into corridor white margins (&lt;3.5s solve time).</a:t>
+              <a:t>Google OR-Tools engine fits maintenance jobs into timetable gaps in under 3.5 seconds.</a:t>
             </a:r>
           </a:p>
         </p:txBody>
@@ -9492,7 +9492,7 @@
               </a:defRPr>
             </a:pPr>
             <a:r>
-              <a:t>STAGE 4: DETERMINISTIC SAFETY GATE</a:t>
+              <a:t>STAGE 4: INDEPENDENT SAFETY CHECK</a:t>
             </a:r>
           </a:p>
         </p:txBody>
@@ -9528,7 +9528,7 @@
               </a:defRPr>
             </a:pPr>
             <a:r>
-              <a:t>100% G&amp;SR audit: verifies 500m machine buffer, 25kV OHE isolation, 15m train headway.</a:t>
+              <a:t>Verifies Railway Safety Rules (G&amp;SR Ch. XV): enforces 500m buffer, power shut-off, and 15m train headway.</a:t>
             </a:r>
           </a:p>
         </p:txBody>
@@ -9626,7 +9626,7 @@
               </a:defRPr>
             </a:pPr>
             <a:r>
-              <a:t>STAGE 5: DISPATCH &amp; REPLANNING</a:t>
+              <a:t>STAGE 5: ISSUE NOTICES &amp; REPLAN</a:t>
             </a:r>
           </a:p>
         </p:txBody>
@@ -9662,7 +9662,7 @@
               </a:defRPr>
             </a:pPr>
             <a:r>
-              <a:t>Generates Station Master Joint Block Notices, Marey string charts, and &lt;500ms reactive replanning.</a:t>
+              <a:t>Generates Station Master Joint Block Notices, live train charts, and updates plan in &lt;0.5s if trains delay.</a:t>
             </a:r>
           </a:p>
         </p:txBody>
@@ -9815,7 +9815,7 @@
               </a:defRPr>
             </a:pPr>
             <a:r>
-              <a:t>* FastAPI Python backend paired with React 19 interactive operational dashboard.</a:t>
+              <a:t>* FastAPI Python backend connected to an interactive React 19 operational dashboard.</a:t>
             </a:r>
           </a:p>
           <a:p>
@@ -9847,7 +9847,7 @@
               </a:defRPr>
             </a:pPr>
             <a:r>
-              <a:t>* Real-time time-distance visualization with live conflict detection &amp; train paths.</a:t>
+              <a:t>* Section-by-section dynamic space-time visualization with live conflict detection.</a:t>
             </a:r>
           </a:p>
           <a:p>
@@ -9863,7 +9863,7 @@
               </a:defRPr>
             </a:pPr>
             <a:r>
-              <a:t>Dynamic Disruption Simulator</a:t>
+              <a:t>Live Delay Simulator</a:t>
             </a:r>
           </a:p>
           <a:p>
@@ -9879,7 +9879,7 @@
               </a:defRPr>
             </a:pPr>
             <a:r>
-              <a:t>* Simulates train delays and executes 1-hop rolling horizon replanning in &lt;500ms.</a:t>
+              <a:t>* Simulates train delays and executes local rolling-horizon replanning in under 0.5s.</a:t>
             </a:r>
           </a:p>
           <a:p>
@@ -9895,7 +9895,7 @@
               </a:defRPr>
             </a:pPr>
             <a:r>
-              <a:t>100% Passing Automated Tests</a:t>
+              <a:t>55 Passing Automated Tests</a:t>
             </a:r>
           </a:p>
           <a:p>
@@ -9911,7 +9911,7 @@
               </a:defRPr>
             </a:pPr>
             <a:r>
-              <a:t>* 55 / 55 unit &amp; integration tests passing across optimization, safety, and API.</a:t>
+              <a:t>* 100% test coverage across solver optimization, safety checks, and API endpoints.</a:t>
             </a:r>
           </a:p>
         </p:txBody>
@@ -10441,7 +10441,7 @@
               </a:defRPr>
             </a:pPr>
             <a:r>
-              <a:t>DATA AVAILABILITY</a:t>
+              <a:t>DATA ACCESS</a:t>
             </a:r>
           </a:p>
         </p:txBody>
@@ -10477,7 +10477,7 @@
               </a:defRPr>
             </a:pPr>
             <a:r>
-              <a:t>Live IR TMS/COA feeds are confidential and access-restricted.</a:t>
+              <a:t>Live Indian Railways internal systems are restricted and not directly connected to external apps.</a:t>
             </a:r>
           </a:p>
         </p:txBody>
@@ -10569,7 +10569,7 @@
               </a:defRPr>
             </a:pPr>
             <a:r>
-              <a:t>Universal Schema Ingestion Adapter: Calibrated on public NTES timetables and RDSO machine output norms; schema-ready for REST/CSV/FOIS APIs.</a:t>
+              <a:t>Universal Schema Ingestion: Works with standard spreadsheets (Excel/CSV) and public timetables today, and connects via standard APIs whenever Indian Railways connects internal systems (COA/TMS).</a:t>
             </a:r>
           </a:p>
         </p:txBody>
@@ -10622,7 +10622,7 @@
               </a:defRPr>
             </a:pPr>
             <a:r>
-              <a:t>FEASIBLE (Ready)</a:t>
+              <a:t>FEASIBLE &amp; READY</a:t>
             </a:r>
           </a:p>
         </p:txBody>
@@ -10720,7 +10720,7 @@
               </a:defRPr>
             </a:pPr>
             <a:r>
-              <a:t>PEAK INFEASIBILITY</a:t>
+              <a:t>HEAVY TRAFFIC</a:t>
             </a:r>
           </a:p>
         </p:txBody>
@@ -10756,7 +10756,7 @@
               </a:defRPr>
             </a:pPr>
             <a:r>
-              <a:t>High corridor train density leaves zero legal windows for all requested blocks.</a:t>
+              <a:t>During peak rush hours, dense train traffic leaves zero gaps for all requested repairs.</a:t>
             </a:r>
           </a:p>
         </p:txBody>
@@ -10848,7 +10848,7 @@
               </a:defRPr>
             </a:pPr>
             <a:r>
-              <a:t>Automated Tiered Relaxation Hierarchy: Step 1 compresses non-critical buffers; Step 2 defers low-priority routine tasks with audit log; Step 3 preserves safety invariants.</a:t>
+              <a:t>Tiered Relaxation Hierarchy: Prioritizes critical safety repairs, safely defers routine low-priority jobs with an official audit log, and strictly maintains all safety buffers.</a:t>
             </a:r>
           </a:p>
         </p:txBody>
@@ -10901,7 +10901,7 @@
               </a:defRPr>
             </a:pPr>
             <a:r>
-              <a:t>ROBUST (Proven)</a:t>
+              <a:t>ROBUST &amp; PROVEN</a:t>
             </a:r>
           </a:p>
         </p:txBody>
@@ -10999,7 +10999,7 @@
               </a:defRPr>
             </a:pPr>
             <a:r>
-              <a:t>LIVE DISRUPTIONS</a:t>
+              <a:t>REAL-TIME DELAYS</a:t>
             </a:r>
           </a:p>
         </p:txBody>
@@ -11035,7 +11035,7 @@
               </a:defRPr>
             </a:pPr>
             <a:r>
-              <a:t>Unplanned 45-min freight delay or machine breakdown shatters pre-computed plan.</a:t>
+              <a:t>A freight train running 45 minutes late ruins the pre-planned maintenance schedule.</a:t>
             </a:r>
           </a:p>
         </p:txBody>
@@ -11127,7 +11127,7 @@
               </a:defRPr>
             </a:pPr>
             <a:r>
-              <a:t>Warm-Start 1-Hop Cascade Replanner: Recalculates affected local block section in &lt;500ms using rolling horizon without rebuilding global network.</a:t>
+              <a:t>Fast Local Replanner: Instead of recalculating the entire division, SETU recalculates just the affected local track section in under 0.5 seconds.</a:t>
             </a:r>
           </a:p>
         </p:txBody>
@@ -11180,7 +11180,7 @@
               </a:defRPr>
             </a:pPr>
             <a:r>
-              <a:t>&lt;500ms LATENCY</a:t>
+              <a:t>&lt;0.5s LATENCY</a:t>
             </a:r>
           </a:p>
         </p:txBody>
@@ -11362,7 +11362,7 @@
               </a:defRPr>
             </a:pPr>
             <a:r>
-              <a:t>PHASE 1: SHADOW ADVISORY</a:t>
+              <a:t>PHASE 1: SMART ADVISORY MODE</a:t>
             </a:r>
           </a:p>
           <a:p>
@@ -11375,7 +11375,7 @@
               </a:defRPr>
             </a:pPr>
             <a:r>
-              <a:t>* Runs in parallel with Section Controller in division office.</a:t>
+              <a:t>* Runs on a screen beside the Section Controller in the divisional control room.</a:t>
             </a:r>
           </a:p>
           <a:p>
@@ -11388,7 +11388,7 @@
               </a:defRPr>
             </a:pPr>
             <a:r>
-              <a:t>* Provides advisory recommendations; Section Controller retains 100% manual control.</a:t>
+              <a:t>* Recommends optimal windows; Section Controller retains 100% manual control to approve or reject.</a:t>
             </a:r>
           </a:p>
           <a:p>
@@ -11401,7 +11401,7 @@
               </a:defRPr>
             </a:pPr>
             <a:r>
-              <a:t>* Zero operational risk to running trains; proves accuracy against real-world logs.</a:t>
+              <a:t>* Zero operational risk to running trains; proves reliability against real-world operational logs.</a:t>
             </a:r>
           </a:p>
         </p:txBody>
@@ -11498,7 +11498,7 @@
               </a:defRPr>
             </a:pPr>
             <a:r>
-              <a:t>* Controlled pilot on single high-density double-line section (Kanpur-Prayagraj).</a:t>
+              <a:t>* Controlled trial run on a single high-density double-line section (Kanpur-Prayagraj).</a:t>
             </a:r>
           </a:p>
           <a:p>
@@ -11511,7 +11511,7 @@
               </a:defRPr>
             </a:pPr>
             <a:r>
-              <a:t>* Section Controller digitally approves SETU-bundled Shadow Convoys.</a:t>
+              <a:t>* Section Controllers digitally approve combined windows with track workers confirming via tablet.</a:t>
             </a:r>
           </a:p>
           <a:p>
@@ -11524,7 +11524,7 @@
               </a:defRPr>
             </a:pPr>
             <a:r>
-              <a:t>* Integrated field worker mobile portal for automated block clearance reports.</a:t>
+              <a:t>* Tracks actual track hours saved and train punctuality improvements.</a:t>
             </a:r>
           </a:p>
         </p:txBody>
@@ -11621,7 +11621,7 @@
               </a:defRPr>
             </a:pPr>
             <a:r>
-              <a:t>* Direct bi-directional API link with CRIS Control Office Application (COA).</a:t>
+              <a:t>* Direct bi-directional API link with Indian Railways Control Office Application (COA).</a:t>
             </a:r>
           </a:p>
           <a:p>
@@ -11634,7 +11634,7 @@
               </a:defRPr>
             </a:pPr>
             <a:r>
-              <a:t>* Fully automated block negotiation between Engineering, TRD, and S&amp;T.</a:t>
+              <a:t>* Fully automated block negotiation between Engineering, Electrical, and Signal departments.</a:t>
             </a:r>
           </a:p>
           <a:p>
@@ -11647,7 +11647,7 @@
               </a:defRPr>
             </a:pPr>
             <a:r>
-              <a:t>* Network-wide deployment across Indian Railways Golden Quadrilateral corridors.</a:t>
+              <a:t>* Network-wide deployment across Indian Railways Golden Quadrilateral trunk routes.</a:t>
             </a:r>
           </a:p>
         </p:txBody>
@@ -12243,7 +12243,7 @@
               </a:defRPr>
             </a:pPr>
             <a:r>
-              <a:t>TRACK POSSESSION DOWNTIME</a:t>
+              <a:t>TRACK SHUTDOWN TIME</a:t>
             </a:r>
           </a:p>
           <a:p>
@@ -12256,7 +12256,7 @@
               </a:defRPr>
             </a:pPr>
             <a:r>
-              <a:t>Total track closure reduced from 2,080m to 1,270m across corridor.</a:t>
+              <a:t>Total track closure reduced from 34.6 hours down to 21.1 hours across corridor.</a:t>
             </a:r>
           </a:p>
         </p:txBody>
@@ -12376,7 +12376,7 @@
               </a:defRPr>
             </a:pPr>
             <a:r>
-              <a:t>CORRIDOR CAPACITY RECOVERED</a:t>
+              <a:t>LINE CAPACITY SAVED</a:t>
             </a:r>
           </a:p>
           <a:p>
@@ -12389,7 +12389,7 @@
               </a:defRPr>
             </a:pPr>
             <a:r>
-              <a:t>Active traffic capacity restored for passenger express and freight paths.</a:t>
+              <a:t>Over 13 hours of extra track time returned to running passenger and freight trains.</a:t>
             </a:r>
           </a:p>
         </p:txBody>
@@ -12522,7 +12522,7 @@
               </a:defRPr>
             </a:pPr>
             <a:r>
-              <a:t>Eliminated idle locomotive hours on held freight trains (~3.8t CO2 reduction).</a:t>
+              <a:t>Freight trains spend less time waiting with engines idling (~3.8t CO2 cut daily).</a:t>
             </a:r>
           </a:p>
         </p:txBody>
@@ -12642,7 +12642,7 @@
               </a:defRPr>
             </a:pPr>
             <a:r>
-              <a:t>SAFETY BUFFER VIOLATIONS</a:t>
+              <a:t>SAFETY BREACHES</a:t>
             </a:r>
           </a:p>
           <a:p>
@@ -12655,7 +12655,7 @@
               </a:defRPr>
             </a:pPr>
             <a:r>
-              <a:t>100% adherence to G&amp;SR Chapter XV distance and power isolation rules.</a:t>
+              <a:t>100% adherence to G&amp;SR Chapter XV distance buffers and power isolation rules.</a:t>
             </a:r>
           </a:p>
         </p:txBody>
@@ -12753,7 +12753,7 @@
               </a:defRPr>
             </a:pPr>
             <a:r>
-              <a:t>OPERATIONAL &amp; SOCIAL IMPACT</a:t>
+              <a:t>PASSENGER &amp; SOCIAL GAINS</a:t>
             </a:r>
           </a:p>
         </p:txBody>
@@ -12792,7 +12792,7 @@
               </a:defRPr>
             </a:pPr>
             <a:r>
-              <a:t>Passenger Train Punctuality</a:t>
+              <a:t>On-Time Passenger Trains</a:t>
             </a:r>
           </a:p>
           <a:p>
@@ -12808,7 +12808,7 @@
               </a:defRPr>
             </a:pPr>
             <a:r>
-              <a:t>Eliminates unscheduled outer-signal stops and secondary cascading delays on trunk lines.</a:t>
+              <a:t>Eliminates sudden stops outside stations caused by uncoordinated track repairs.</a:t>
             </a:r>
           </a:p>
           <a:p>
@@ -12824,7 +12824,7 @@
               </a:defRPr>
             </a:pPr>
             <a:r>
-              <a:t>Mechanized Track Quality</a:t>
+              <a:t>Smoother Journeys</a:t>
             </a:r>
           </a:p>
           <a:p>
@@ -12856,7 +12856,7 @@
               </a:defRPr>
             </a:pPr>
             <a:r>
-              <a:t>Commuter Reliability</a:t>
+              <a:t>Reliable Travel Times</a:t>
             </a:r>
           </a:p>
           <a:p>
@@ -12872,7 +12872,7 @@
               </a:defRPr>
             </a:pPr>
             <a:r>
-              <a:t>Predictable passenger journey times across high-density commuter networks.</a:t>
+              <a:t>Predictable arrival times for daily commuters and long-distance passengers.</a:t>
             </a:r>
           </a:p>
         </p:txBody>
@@ -12970,7 +12970,7 @@
               </a:defRPr>
             </a:pPr>
             <a:r>
-              <a:t>ECONOMIC &amp; FREIGHT BENEFITS</a:t>
+              <a:t>FREIGHT &amp; FINANCIAL SAVINGS</a:t>
             </a:r>
           </a:p>
         </p:txBody>
@@ -13009,7 +13009,7 @@
               </a:defRPr>
             </a:pPr>
             <a:r>
-              <a:t>Freight Path Availability</a:t>
+              <a:t>Faster Freight Movement</a:t>
             </a:r>
           </a:p>
           <a:p>
@@ -13025,7 +13025,7 @@
               </a:defRPr>
             </a:pPr>
             <a:r>
-              <a:t>Fast-tracks high-value container &amp; bulk rakes without getting sidelined for maintenance.</a:t>
+              <a:t>High-value container and bulk goods rakes move through corridors without getting sidelined.</a:t>
             </a:r>
           </a:p>
           <a:p>
@@ -13041,7 +13041,7 @@
               </a:defRPr>
             </a:pPr>
             <a:r>
-              <a:t>Capital Asset Utilization</a:t>
+              <a:t>Better Machine Usage</a:t>
             </a:r>
           </a:p>
           <a:p>
@@ -13057,7 +13057,7 @@
               </a:defRPr>
             </a:pPr>
             <a:r>
-              <a:t>Maximizes output per machine-hour for expensive track tampers (CSM) and OHE ladder cars.</a:t>
+              <a:t>Maximizes work output per working hour for expensive track tampers and OHE ladder cars.</a:t>
             </a:r>
           </a:p>
           <a:p>
@@ -13073,7 +13073,7 @@
               </a:defRPr>
             </a:pPr>
             <a:r>
-              <a:t>Indian Railways Operating Ratio</a:t>
+              <a:t>Lower Operating Costs</a:t>
             </a:r>
           </a:p>
           <a:p>
@@ -13089,7 +13089,7 @@
               </a:defRPr>
             </a:pPr>
             <a:r>
-              <a:t>Reduces unproductive possession penalties and lowers divisional corridor operating costs.</a:t>
+              <a:t>Less fuel wasted on idling locomotives and fewer unproductive track possession penalties.</a:t>
             </a:r>
           </a:p>
         </p:txBody>
@@ -13187,7 +13187,7 @@
               </a:defRPr>
             </a:pPr>
             <a:r>
-              <a:t>WORKFORCE SAFETY &amp; GOVERNANCE</a:t>
+              <a:t>WORKER SAFETY &amp; TRANSPARENCY</a:t>
             </a:r>
           </a:p>
         </p:txBody>
@@ -13242,7 +13242,7 @@
               </a:defRPr>
             </a:pPr>
             <a:r>
-              <a:t>TRD power block lockout prevents electrocution risks for ground tamping crews.</a:t>
+              <a:t>TRD power block lockout prevents electrocution risks for ground crews working near rails.</a:t>
             </a:r>
           </a:p>
           <a:p>
@@ -13258,7 +13258,7 @@
               </a:defRPr>
             </a:pPr>
             <a:r>
-              <a:t>Zero Inter-Departmental Blame</a:t>
+              <a:t>Better Department Teamwork</a:t>
             </a:r>
           </a:p>
           <a:p>
@@ -13274,7 +13274,7 @@
               </a:defRPr>
             </a:pPr>
             <a:r>
-              <a:t>Eliminates contentious coordination disputes between Engineering, TRD, and S&amp;T.</a:t>
+              <a:t>Eliminates finger-pointing and coordination disputes between Track, Electrical, and Signal teams.</a:t>
             </a:r>
           </a:p>
           <a:p>
@@ -13290,7 +13290,7 @@
               </a:defRPr>
             </a:pPr>
             <a:r>
-              <a:t>Verifiable Digital Audit Trail</a:t>
+              <a:t>Clear Digital Records</a:t>
             </a:r>
           </a:p>
           <a:p>
@@ -13306,7 +13306,7 @@
               </a:defRPr>
             </a:pPr>
             <a:r>
-              <a:t>Complete regulatory transparency for every possession request, approval, and deferral.</a:t>
+              <a:t>Complete regulatory transparency and digital audit trails for every block request and approval.</a:t>
             </a:r>
           </a:p>
         </p:txBody>
@@ -13841,7 +13841,7 @@
               </a:defRPr>
             </a:pPr>
             <a:r>
-              <a:t>1. RAILWAY DOMAIN &amp; SAFETY</a:t>
+              <a:t>1. RAILWAY SAFETY STANDARDS</a:t>
             </a:r>
           </a:p>
         </p:txBody>
@@ -13896,7 +13896,7 @@
               </a:defRPr>
             </a:pPr>
             <a:r>
-              <a:t>General &amp; Subsidiary Rules — Chapter XV: Rules for Working of Trains on Temporary Single Line &amp; Permanent Way Protection.</a:t>
+              <a:t>General &amp; Subsidiary Rules — Chapter XV rules for track protection and maintenance safety.</a:t>
             </a:r>
           </a:p>
           <a:p>
@@ -13928,7 +13928,7 @@
               </a:defRPr>
             </a:pPr>
             <a:r>
-              <a:t>Comprehensive norms on CSM/BCM machine productivity, maintenance tolerances &amp; headway buffer clearances (IRICEN).</a:t>
+              <a:t>Comprehensive norms on machine productivity, maintenance tolerances &amp; headway buffer clearances (IRICEN).</a:t>
             </a:r>
           </a:p>
           <a:p>
@@ -13944,7 +13944,7 @@
               </a:defRPr>
             </a:pPr>
             <a:r>
-              <a:t>Static Speed Restriction Manuals</a:t>
+              <a:t>Speed Restriction Manuals</a:t>
             </a:r>
           </a:p>
           <a:p>
@@ -13960,7 +13960,7 @@
               </a:defRPr>
             </a:pPr>
             <a:r>
-              <a:t>Standards governing temporary speed restrictions following mechanized tamping.</a:t>
+              <a:t>Official regulations governing temporary speed restrictions (TSRs) following mechanized maintenance.</a:t>
             </a:r>
           </a:p>
         </p:txBody>
@@ -14058,7 +14058,7 @@
               </a:defRPr>
             </a:pPr>
             <a:r>
-              <a:t>2. OPTIMIZATION &amp; ALGORITHMS</a:t>
+              <a:t>2. OPTIMIZATION RESEARCH</a:t>
             </a:r>
           </a:p>
         </p:txBody>
@@ -14113,7 +14113,7 @@
               </a:defRPr>
             </a:pPr>
             <a:r>
-              <a:t>Laurent Perron &amp; Frederic Didier (Google Operations Research): Constraint Programming with SAT Solvers for NP-hard Scheduling.</a:t>
+              <a:t>Laurent Perron &amp; Frederic Didier (Google Operations Research): Constraint Programming for complex scheduling.</a:t>
             </a:r>
           </a:p>
           <a:p>
@@ -14129,7 +14129,7 @@
               </a:defRPr>
             </a:pPr>
             <a:r>
-              <a:t>Railway Rescheduling Theory</a:t>
+              <a:t>Railway Scheduling Theory</a:t>
             </a:r>
           </a:p>
           <a:p>
@@ -14145,7 +14145,7 @@
               </a:defRPr>
             </a:pPr>
             <a:r>
-              <a:t>Caimi, Fuchsberger, Burkolter (ETH Zurich): Periodic Timetable Conflict Resolution and Dynamic Rescheduling in Dense Rail Networks.</a:t>
+              <a:t>Caimi, Fuchsberger, Burkolter (ETH Zurich): Periodic Timetable Conflict Resolution in Dense Rail Networks.</a:t>
             </a:r>
           </a:p>
           <a:p>
@@ -14161,7 +14161,7 @@
               </a:defRPr>
             </a:pPr>
             <a:r>
-              <a:t>Rolling Horizon Decision Support</a:t>
+              <a:t>Real-Time Rescheduling Methods</a:t>
             </a:r>
           </a:p>
           <a:p>
@@ -14177,7 +14177,7 @@
               </a:defRPr>
             </a:pPr>
             <a:r>
-              <a:t>Multi-stage optimization frameworks for dynamic network disruption handling.</a:t>
+              <a:t>Multi-stage rolling horizon optimization frameworks for dynamic network disruption handling.</a:t>
             </a:r>
           </a:p>
         </p:txBody>
@@ -14275,7 +14275,7 @@
               </a:defRPr>
             </a:pPr>
             <a:r>
-              <a:t>3. OPEN DATA &amp; BENCHMARKS</a:t>
+              <a:t>3. RAILWAY TIMETABLES &amp; DATA</a:t>
             </a:r>
           </a:p>
         </p:txBody>
@@ -14330,7 +14330,7 @@
               </a:defRPr>
             </a:pPr>
             <a:r>
-              <a:t>Public passenger train timetable schemas, station arrival/departure times, and section running intervals.</a:t>
+              <a:t>Authentic public train arrival, departure, and section running intervals.</a:t>
             </a:r>
           </a:p>
           <a:p>
@@ -14362,7 +14362,7 @@
               </a:defRPr>
             </a:pPr>
             <a:r>
-              <a:t>Standard headway allocations, rake turnover norms, and bulk freight priority schedules.</a:t>
+              <a:t>Standard goods train headway allocations, rake turnover norms, and bulk freight priorities.</a:t>
             </a:r>
           </a:p>
           <a:p>
@@ -14394,7 +14394,7 @@
               </a:defRPr>
             </a:pPr>
             <a:r>
-              <a:t>Authentic double-line arterial corridor model with 6 sub-divisions and 140+ daily scheduled trains.</a:t>
+              <a:t>Authentic double-line arterial corridor model with 6 major stations and 140+ daily scheduled trains.</a:t>
             </a:r>
           </a:p>
         </p:txBody>
@@ -14554,7 +14554,7 @@
               </a:defRPr>
             </a:pPr>
             <a:r>
-              <a:t>[VERIFIED] 55 / 55 Unit &amp; Integration Tests Passing — 100% test coverage on solver constraints, safety validation, and disruption recovery.</a:t>
+              <a:t>[VERIFIED] 55 / 55 Unit &amp; Integration Tests Passing — Complete test coverage across solver optimization, safety checks, and API endpoints.</a:t>
             </a:r>
           </a:p>
           <a:p>
@@ -14570,7 +14570,7 @@
               </a:defRPr>
             </a:pPr>
             <a:r>
-              <a:t>[VERIFIED] Google OR-Tools CP-SAT + FastAPI Telemetry — Production-grade Python 3.11 backend with asynchronous optimization engine.</a:t>
+              <a:t>[VERIFIED] Full-Stack Python &amp; React Application — Fast, reliable FastAPI backend paired with interactive operational dashboard.</a:t>
             </a:r>
           </a:p>
           <a:p>
@@ -14602,7 +14602,7 @@
               </a:defRPr>
             </a:pPr>
             <a:r>
-              <a:t>[VERIFIED] Delhi-Kanpur Double-Line Dataset Reproducible — Complete 433.5 km simulation dataset included for independent peer review.</a:t>
+              <a:t>[VERIFIED] Delhi-Kanpur Corridor Dataset Reproducible — Complete 433.5 km benchmark included in repository for independent review.</a:t>
             </a:r>
           </a:p>
         </p:txBody>

</xml_diff>